<commit_message>
update(reports): made it all consistent
</commit_message>
<xml_diff>
--- a/reports/presentation/InsightfulCell_CodeFair_2026.pptx
+++ b/reports/presentation/InsightfulCell_CodeFair_2026.pptx
@@ -580,7 +580,7 @@
           <a:p>
             <a:r>
               <a:rPr lang="en-US" dirty="0"/>
-              <a:t>Open with the promise in the title. InsightfulCell is a web platform: you upload a table and get back a cleaned dataset, statistically tested findings, checked charts and maps, and a report in plain language. The phrase 'every number shows its work' is literal: every figure in the product links to a stored, unchangeable fact you can inspect. It is live today on AWS at app.ic.rgproject.me. Introduce the team: Rupesh built the product end to end; Sandesh took it from local to the hosted AWS deployment.</a:t>
+              <a:t>Open with the tagline from the site: your one stop solution for data analysis. InsightfulCell is a web platform: you upload a table and get back a cleaned dataset, statistically tested findings, checked charts and maps, and a report in plain language. You need no statistics background and no data analytics specialist, and your raw rows never reach an AI model. Every figure links to a stored fact that cannot change, so you can check where it came from. It is live on AWS at app.ic.rgproject.me. Introduce the team: Rupesh built the product end to end; Sandesh took it from local to the hosted AWS deployment.</a:t>
             </a:r>
             <a:endParaRPr lang="en-US" dirty="0"/>
           </a:p>
@@ -756,7 +756,7 @@
           <a:p>
             <a:r>
               <a:rPr lang="en-US" dirty="0"/>
-              <a:t>Privacy is tenet three. The recipe page shows, word for word, the description a planning model would be sent: flagged 'personal_data_masked: true', with no rows, no personal values and rounded ranges only. A single gateway is the only code allowed to call a model; it blocks any payload containing personal data, enforces budgets and a hard spend cap, and records every call without prompt text. Importantly, the model is optional: the deployed site currently has none configured, and everything you saw was planned by our rules engine and written from templates.</a:t>
+              <a:t>Privacy is tenet three. The recipe page shows, word for word, the description a planning model would be sent: flagged 'personal_data_masked: true', with no rows, no personal values and rounded ranges only. A single gateway is the only code allowed to call a model; it blocks any payload containing personal data, enforces budgets and a hard spend cap, and records every call without prompt text. The model is optional: the deployed site currently has none configured, and everything you saw was planned by our rules engine and written from templates.</a:t>
             </a:r>
             <a:endParaRPr lang="en-US" dirty="0"/>
           </a:p>
@@ -1108,7 +1108,7 @@
           <a:p>
             <a:r>
               <a:rPr lang="en-US" dirty="0"/>
-              <a:t>This mechanism is what makes hallucinated numbers structurally impossible. The engine stores each finding as a fact. The writer, model or template, can only refer to numbers through slots. The engine fills them from the fact. Then a verifier checks every sentence for missing citations, stray numbers, wrong direction, wording that overstates the effect size, causal language and missing conditions. A failing sentence gets one rewrite, then falls back to the fact's own plain statement. Our evaluation suite plants 31 deliberate errors in narration; all 31 are rejected while 11 clean sentences are kept.</a:t>
+              <a:t>Because of this mechanism, a model cannot put a made-up number in the report. The engine stores each finding as a fact. The writer, model or template, can only refer to numbers through slots. The engine fills them from the fact. Then a verifier checks every sentence for missing citations, stray numbers, wrong direction, wording that overstates the effect size, causal language and missing conditions. A failing sentence gets one rewrite, then falls back to the fact's own plain statement. Our evaluation suite plants 31 deliberate errors in narration; all 31 are rejected while 11 clean sentences are kept.</a:t>
             </a:r>
             <a:endParaRPr lang="en-US" dirty="0"/>
           </a:p>
@@ -1196,7 +1196,7 @@
           <a:p>
             <a:r>
               <a:rPr lang="en-US" dirty="0"/>
-              <a:t>For an academic audience: testing many hypotheses on one table inflates false positives. We control the false-discovery rate at 5% across the whole run with Benjamini–Hochberg, using every test in a persistent test log. Derived features must beat 19 random permutations, which is a 5% level permutation test. The ten strongest findings are re-tested on data with only lossless cleaning, to rule out findings created by our own cleaning. Findings are tiered honestly, and the verifier rejects causal language because correlational analysis cannot support it.</a:t>
+              <a:t>For an academic audience: testing many hypotheses on one table inflates false positives. We control the false-discovery rate at 5% across the whole run with Benjamini-Hochberg, using every test in a persistent test log. Derived features must beat 19 random permutations, which is a 5% level permutation test. The ten strongest findings are re-tested on data with only lossless cleaning, to rule out findings created by our own cleaning. Findings are tiered honestly, and the verifier rejects causal language because correlational analysis cannot support it.</a:t>
             </a:r>
             <a:endParaRPr lang="en-US" dirty="0"/>
           </a:p>
@@ -1284,7 +1284,7 @@
           <a:p>
             <a:r>
               <a:rPr lang="en-US" dirty="0"/>
-              <a:t>Security is designed into the data layer, not bolted on. Every tenant query runs in a transaction that sets the organisation from the verified token, and every tenant table has forced row-level security, so even a bug in our service code cannot read another organisation's rows. In our 18 October system test, all 22 cross-tenant attacks failed. Tokens are short-lived and never reach page scripts. Results are tamper-evident. Uploads are treated as hostile. And because this runs as a public demo, a hard spend cap reserves the worst-case cost of each model call before it is made.</a:t>
+              <a:t>Security starts in the data layer. Every tenant query runs in a transaction that sets the organisation from the verified token, and every tenant table has forced row-level security, so even a bug in our service code cannot read another organisation's rows. In our 18 October system test, all 22 cross-tenant attacks failed. Tokens are short-lived and never reach page scripts. Results are tamper-evident. Uploads are treated as hostile. And because this runs as a public demo, a hard spend cap reserves the worst-case cost of each model call before it is made.</a:t>
             </a:r>
             <a:endParaRPr lang="en-US" dirty="0"/>
           </a:p>
@@ -1372,7 +1372,7 @@
           <a:p>
             <a:r>
               <a:rPr lang="en-US" dirty="0"/>
-              <a:t>The product is deployed, not just a local demo. One free-tier EC2 instance runs PostgreSQL, the API, the worker and the web app under Docker Compose. A shared Caddy proxy provides automatic HTTPS. GitHub Actions builds the images on every push, because a 1 GB server cannot build the web app; the server only pulls them, and rolling back is deploying an earlier commit's images. Uploads go straight to a private S3 bucket using the instance role, so there are no keys in config files, and the database is dumped to a backups bucket every night. The only code change needed for AWS was signing upload links for the bucket's regional host. Credit to Sandesh for the deployment.</a:t>
+              <a:t>The product runs in production. One free-tier EC2 instance runs PostgreSQL, the API, the worker and the web app under Docker Compose. A shared Caddy proxy provides automatic HTTPS. GitHub Actions builds the images on every push, because a 1 GB server cannot build the web app; the server only pulls them, and rolling back is deploying an earlier commit's images. Uploads go straight to a private S3 bucket using the instance role, so there are no keys in config files, and the database is dumped to a backups bucket every night. The only code change needed for AWS was signing upload links for the bucket's regional host. Credit to Sandesh for the deployment.</a:t>
             </a:r>
             <a:endParaRPr lang="en-US" dirty="0"/>
           </a:p>
@@ -1460,7 +1460,7 @@
           <a:p>
             <a:r>
               <a:rPr lang="en-US" dirty="0"/>
-              <a:t>Quality is measured, not claimed. 719 backend tests including integration tests on a real PostgreSQL with row-level security and real S3; 93% line coverage on the last full gate on 21 October; 422 frontend tests, each component with an automated accessibility check; and six architecture contracts so the analysis engine can never import web or database code. The same script runs locally and in CI. Plus two evaluation suites: planted statistical effects that must be found, and planted narration errors that must be rejected.</a:t>
+              <a:t>The measures: 719 backend tests including integration tests on a real PostgreSQL with row-level security and real S3; 93% line coverage on the last full gate on 21 October; 422 frontend tests, each component with an automated accessibility check; and six architecture contracts so the analysis engine can never import web or database code. The same script runs locally and in CI. Plus two evaluation suites: planted statistical effects that must be found, and planted narration errors that must be rejected.</a:t>
             </a:r>
             <a:endParaRPr lang="en-US" dirty="0"/>
           </a:p>
@@ -1548,7 +1548,7 @@
           <a:p>
             <a:r>
               <a:rPr lang="en-US" dirty="0"/>
-              <a:t>Frame the problem. People who own a spreadsheet want answers, not a statistics course. Today they choose between two imperfect options. General-purpose AI assistants are fluent but their numbers can be made up, their cleaning is invisible, and sending customer rows to a model is unacceptable for sensitive data. Traditional BI and statistics tools are accurate but need a skilled analyst. Our project started from one question, which is also our academic research question: can analysis be as easy as an assistant and as trustworthy as a careful analyst?</a:t>
+              <a:t>Frame the problem. People who own a spreadsheet want answers, and most of them have no statistics background. Today they choose between two imperfect options. General-purpose AI assistants are fluent but their numbers can be made up, their cleaning is invisible, and sending customer rows to a model is unacceptable for sensitive data. Traditional BI and statistics tools are accurate but need a skilled analyst. Our project started from one question, which is also our academic research question: can analysis be as easy as an assistant and as trustworthy as a careful analyst? The idea came from what models can already do: language models handle almost any text, and newer systems predict on tabular data without being retrained each time. So why not a system that gives a detailed analysis, keeps the data private and needs no data analytics specialist?</a:t>
             </a:r>
             <a:endParaRPr lang="en-US" dirty="0"/>
           </a:p>
@@ -1900,7 +1900,7 @@
           <a:p>
             <a:r>
               <a:rPr lang="en-US" dirty="0"/>
-              <a:t>In the academic spirit, we state our limitations. Our own system test found that automatic cleaning heuristics can change data silently in some cases, such as percentage columns on a 0 to 100 scale, decimal commas and close-sounding category names; manual review avoids this until the heuristics are fixed. Natural-language Q&amp;A is the next phase. Production is a single small server without monitoring. Our lessons: trust is won or lost in data preparation; building AI as optional made the product cheaper and more robust; and a real deployment surfaced a bug local tests could not, the S3 regional host.</a:t>
+              <a:t>In the academic spirit, we state our limitations. Our own system test found that automatic cleaning heuristics can change data silently in some cases, such as percentage columns on a 0 to 100 scale, decimal commas and close-sounding category names; manual review avoids this until the heuristics are fixed. Natural-language Q&amp;A is the next phase. Production is a single small server without monitoring. Our lessons: trust depends most on data preparation; building AI as optional made the product cheaper and more robust; and a real deployment surfaced a bug local tests could not, the S3 regional host.</a:t>
             </a:r>
             <a:endParaRPr lang="en-US" dirty="0"/>
           </a:p>
@@ -2076,7 +2076,7 @@
           <a:p>
             <a:r>
               <a:rPr lang="en-US" dirty="0"/>
-              <a:t>Close with the recap: every number traces to an immutable, hashed fact; raw rows never reach a language model; false discoveries are controlled across the whole run; and the product works fully without AI and is live on AWS today. Invite the audience to try app.ic.rgproject.me and take questions.</a:t>
+              <a:t>Close with the recap: a one stop solution for data analysis. Every number traces to a hashed fact that cannot change, raw rows never reach an AI model, you need no analyst or statistics background, and the product works fully without AI and is live on AWS today. Invite the audience to try app.ic.rgproject.me and take questions.</a:t>
             </a:r>
             <a:endParaRPr lang="en-US" dirty="0"/>
           </a:p>
@@ -2164,7 +2164,7 @@
           <a:p>
             <a:r>
               <a:rPr lang="en-US" dirty="0"/>
-              <a:t>This is the core design idea. Code computes; the language model only plans and writes; everything is checked. When two goals conflict we follow a fixed priority: correctness beats fluency, then traceability, then privacy, then simplicity of operation. So a plain, exact sentence always wins over a smooth, wrong one. These tenets are enforced in code and in tests, not just written down.</a:t>
+              <a:t>This is the core design idea. Code computes; the language model only plans and writes; everything is checked. When two goals conflict we follow a fixed priority: correctness beats fluency, then traceability, then privacy, then simplicity of operation. So a plain, exact sentence always wins over a smooth, wrong one. Code and tests enforce these tenets.</a:t>
             </a:r>
             <a:endParaRPr lang="en-US" dirty="0"/>
           </a:p>
@@ -2604,7 +2604,7 @@
           <a:p>
             <a:r>
               <a:rPr lang="en-US" dirty="0"/>
-              <a:t>This is the heart of the trust story. The report's 'In short' section and every answer cite facts like F13. Clicking a chip opens the fact inspector: the statement, an evidence badge (Strong evidence), the columns and 5,000 rows used, the method (Spearman rank correlation), the 95% interval, the p-value before and after false-discovery control, and a content hash. Facts are append-only in the database; updates and deletes are rejected by triggers.</a:t>
+              <a:t>The report's 'In short' section and every answer cite facts like F13. Clicking a chip opens the fact inspector: the statement, an evidence badge (Strong evidence), the columns and 5,000 rows used, the method (Spearman rank correlation), the 95% interval, the p-value before and after false-discovery control, and a content hash. Facts are append-only in the database; updates and deletes are rejected by triggers.</a:t>
             </a:r>
             <a:endParaRPr lang="en-US" dirty="0"/>
           </a:p>
@@ -3711,7 +3711,7 @@
                 <a:ea typeface="Cambria" pitchFamily="34" charset="-122"/>
                 <a:cs typeface="Cambria" pitchFamily="34" charset="-120"/>
               </a:rPr>
-              <a:t>Every number shows its work</a:t>
+              <a:t>Your one stop solution for data analysis.</a:t>
             </a:r>
             <a:endParaRPr lang="en-US" sz="4600" dirty="0"/>
           </a:p>
@@ -3752,7 +3752,7 @@
                 <a:ea typeface="Calibri" pitchFamily="34" charset="-122"/>
                 <a:cs typeface="Calibri" pitchFamily="34" charset="-120"/>
               </a:rPr>
-              <a:t>A verified, privacy-first platform that turns a spreadsheet into tested findings, checked charts and a plain-language report.</a:t>
+              <a:t>Bring a spreadsheet. Leave with clear answers, charts and a report your team can check.</a:t>
             </a:r>
             <a:endParaRPr lang="en-US" sz="1800" dirty="0"/>
           </a:p>
@@ -8617,7 +8617,7 @@
                   <a:schemeClr val="tx1"/>
                 </a:solidFill>
               </a:rPr>
-              <a:t>False-discovery rate, controlled across the whole run (Benjamini–Hochberg), not per test</a:t>
+              <a:t>False-discovery rate, controlled across the whole run (Benjamini-Hochberg), not per test</a:t>
             </a:r>
             <a:endParaRPr lang="en-US" sz="1500" dirty="0"/>
           </a:p>
@@ -16701,7 +16701,7 @@
                   <a:schemeClr val="accent5"/>
                 </a:solidFill>
               </a:rPr>
-              <a:t>in a few cases (0–100 percentage columns, decimal commas, close-sounding names). Use Manual review for sensitive work until fixed.</a:t>
+              <a:t>in a few cases (0-100 percentage columns, decimal commas, close-sounding names). Use Manual review for sensitive work until fixed.</a:t>
             </a:r>
             <a:endParaRPr lang="en-US" sz="1400" dirty="0"/>
           </a:p>
@@ -17086,7 +17086,7 @@
                   <a:schemeClr val="tx1"/>
                 </a:solidFill>
               </a:rPr>
-              <a:t>Data preparation, not statistics, is where trust is won or lost</a:t>
+              <a:t>Trust depends on data preparation more than on the statistics</a:t>
             </a:r>
             <a:endParaRPr lang="en-US" sz="1400" dirty="0"/>
           </a:p>
@@ -17380,7 +17380,7 @@
                 <a:ea typeface="Cambria" pitchFamily="34" charset="-122"/>
                 <a:cs typeface="Cambria" pitchFamily="34" charset="-120"/>
               </a:rPr>
-              <a:t>Phases 0–6</a:t>
+              <a:t>Phases 0-6</a:t>
             </a:r>
             <a:endParaRPr lang="en-US" sz="1400" dirty="0"/>
           </a:p>
@@ -18528,7 +18528,7 @@
                 <a:ea typeface="Calibri" pitchFamily="34" charset="-122"/>
                 <a:cs typeface="Calibri" pitchFamily="34" charset="-120"/>
               </a:rPr>
-              <a:t>Code computes, the model only writes, and every number shows its work.</a:t>
+              <a:t>Your one stop solution for data analysis.</a:t>
             </a:r>
             <a:endParaRPr lang="en-US" sz="1800" dirty="0"/>
           </a:p>
@@ -18754,7 +18754,7 @@
                   <a:srgbClr val="E8E6E1"/>
                 </a:solidFill>
               </a:rPr>
-              <a:t>Raw rows never reach a language model</a:t>
+              <a:t>Your data stays private: raw rows never reach an AI model</a:t>
             </a:r>
             <a:endParaRPr lang="en-US" sz="1500" dirty="0"/>
           </a:p>
@@ -18772,7 +18772,7 @@
                   <a:srgbClr val="E8E6E1"/>
                 </a:solidFill>
               </a:rPr>
-              <a:t>False discoveries controlled across the whole run</a:t>
+              <a:t>No analyst or statistics background needed</a:t>
             </a:r>
             <a:endParaRPr lang="en-US" sz="1500" dirty="0"/>
           </a:p>
@@ -20720,7 +20720,7 @@
                   <a:schemeClr val="tx1"/>
                 </a:solidFill>
               </a:rPr>
-              <a:t>Meaning, not just type: </a:t>
+              <a:t>A meaning for each column: </a:t>
             </a:r>
             <a:pPr indent="0" marL="0">
               <a:spcAft>

</xml_diff>